<commit_message>
Add corrected presentation for VHDL implementation of neural network for wildfire detection
</commit_message>
<xml_diff>
--- a/docs/thesis/Presentation/VHDL implementation of neural network for Wildfire Detection.pptx
+++ b/docs/thesis/Presentation/VHDL implementation of neural network for Wildfire Detection.pptx
@@ -239,7 +239,7 @@
           <a:p>
             <a:fld id="{D8962055-B13C-4613-83A1-B4299BCABB00}" type="datetimeFigureOut">
               <a:rPr lang="en-US" smtClean="0"/>
-              <a:t>2/24/2026</a:t>
+              <a:t>3/16/2026</a:t>
             </a:fld>
             <a:endParaRPr lang="en-US"/>
           </a:p>
@@ -744,7 +744,7 @@
           <a:p>
             <a:fld id="{5BCAD085-E8A6-8845-BD4E-CB4CCA059FC4}" type="datetimeFigureOut">
               <a:rPr lang="en-US" smtClean="0"/>
-              <a:t>2/24/2026</a:t>
+              <a:t>3/16/2026</a:t>
             </a:fld>
             <a:endParaRPr lang="en-US"/>
           </a:p>
@@ -914,7 +914,7 @@
           <a:p>
             <a:fld id="{5BCAD085-E8A6-8845-BD4E-CB4CCA059FC4}" type="datetimeFigureOut">
               <a:rPr lang="en-US" smtClean="0"/>
-              <a:t>2/24/2026</a:t>
+              <a:t>3/16/2026</a:t>
             </a:fld>
             <a:endParaRPr lang="en-US"/>
           </a:p>
@@ -1094,7 +1094,7 @@
           <a:p>
             <a:fld id="{5BCAD085-E8A6-8845-BD4E-CB4CCA059FC4}" type="datetimeFigureOut">
               <a:rPr lang="en-US" smtClean="0"/>
-              <a:t>2/24/2026</a:t>
+              <a:t>3/16/2026</a:t>
             </a:fld>
             <a:endParaRPr lang="en-US"/>
           </a:p>
@@ -1264,7 +1264,7 @@
           <a:p>
             <a:fld id="{5BCAD085-E8A6-8845-BD4E-CB4CCA059FC4}" type="datetimeFigureOut">
               <a:rPr lang="en-US" smtClean="0"/>
-              <a:t>2/24/2026</a:t>
+              <a:t>3/16/2026</a:t>
             </a:fld>
             <a:endParaRPr lang="en-US"/>
           </a:p>
@@ -1532,7 +1532,7 @@
           <a:p>
             <a:fld id="{5BCAD085-E8A6-8845-BD4E-CB4CCA059FC4}" type="datetimeFigureOut">
               <a:rPr lang="en-US" smtClean="0"/>
-              <a:t>2/24/2026</a:t>
+              <a:t>3/16/2026</a:t>
             </a:fld>
             <a:endParaRPr lang="en-US"/>
           </a:p>
@@ -1764,7 +1764,7 @@
           <a:p>
             <a:fld id="{5BCAD085-E8A6-8845-BD4E-CB4CCA059FC4}" type="datetimeFigureOut">
               <a:rPr lang="en-US" smtClean="0"/>
-              <a:t>2/24/2026</a:t>
+              <a:t>3/16/2026</a:t>
             </a:fld>
             <a:endParaRPr lang="en-US"/>
           </a:p>
@@ -2123,7 +2123,7 @@
           <a:p>
             <a:fld id="{5BCAD085-E8A6-8845-BD4E-CB4CCA059FC4}" type="datetimeFigureOut">
               <a:rPr lang="en-US" smtClean="0"/>
-              <a:t>2/24/2026</a:t>
+              <a:t>3/16/2026</a:t>
             </a:fld>
             <a:endParaRPr lang="en-US"/>
           </a:p>
@@ -2264,7 +2264,7 @@
           <a:p>
             <a:fld id="{5BCAD085-E8A6-8845-BD4E-CB4CCA059FC4}" type="datetimeFigureOut">
               <a:rPr lang="en-US" smtClean="0"/>
-              <a:t>2/24/2026</a:t>
+              <a:t>3/16/2026</a:t>
             </a:fld>
             <a:endParaRPr lang="en-US"/>
           </a:p>
@@ -2359,7 +2359,7 @@
           <a:p>
             <a:fld id="{5BCAD085-E8A6-8845-BD4E-CB4CCA059FC4}" type="datetimeFigureOut">
               <a:rPr lang="en-US" smtClean="0"/>
-              <a:t>2/24/2026</a:t>
+              <a:t>3/16/2026</a:t>
             </a:fld>
             <a:endParaRPr lang="en-US"/>
           </a:p>
@@ -2716,7 +2716,7 @@
           <a:p>
             <a:fld id="{5BCAD085-E8A6-8845-BD4E-CB4CCA059FC4}" type="datetimeFigureOut">
               <a:rPr lang="en-US" smtClean="0"/>
-              <a:t>2/24/2026</a:t>
+              <a:t>3/16/2026</a:t>
             </a:fld>
             <a:endParaRPr lang="en-US"/>
           </a:p>
@@ -3075,7 +3075,7 @@
           <a:p>
             <a:fld id="{5BCAD085-E8A6-8845-BD4E-CB4CCA059FC4}" type="datetimeFigureOut">
               <a:rPr lang="en-US" smtClean="0"/>
-              <a:t>2/24/2026</a:t>
+              <a:t>3/16/2026</a:t>
             </a:fld>
             <a:endParaRPr lang="en-US"/>
           </a:p>
@@ -3318,7 +3318,7 @@
           <a:p>
             <a:fld id="{5BCAD085-E8A6-8845-BD4E-CB4CCA059FC4}" type="datetimeFigureOut">
               <a:rPr lang="en-US" smtClean="0"/>
-              <a:t>2/24/2026</a:t>
+              <a:t>3/16/2026</a:t>
             </a:fld>
             <a:endParaRPr lang="en-US"/>
           </a:p>
@@ -3793,24 +3793,16 @@
           <a:lstStyle/>
           <a:p>
             <a:r>
-              <a:rPr lang="en-US" dirty="0" smtClean="0"/>
+              <a:rPr lang="en-US" dirty="0"/>
               <a:t>Neural Network </a:t>
             </a:r>
             <a:r>
-              <a:rPr dirty="0" smtClean="0"/>
-              <a:t>for </a:t>
-            </a:r>
-            <a:r>
               <a:rPr dirty="0"/>
-              <a:t>Wildfire </a:t>
-            </a:r>
-            <a:r>
-              <a:rPr dirty="0" smtClean="0"/>
-              <a:t>Detection</a:t>
-            </a:r>
-            <a:r>
-              <a:rPr lang="en-US" dirty="0" smtClean="0"/>
-              <a:t>: a VHDL approach</a:t>
+              <a:t>for Wildfire Detection</a:t>
+            </a:r>
+            <a:r>
+              <a:rPr lang="en-US" dirty="0"/>
+              <a:t>: a hardware design approach</a:t>
             </a:r>
             <a:endParaRPr dirty="0"/>
           </a:p>
@@ -3972,56 +3964,28 @@
                 <a:latin typeface="Times New Roman" panose="02020603050405020304" pitchFamily="18" charset="0"/>
                 <a:cs typeface="Times New Roman" panose="02020603050405020304" pitchFamily="18" charset="0"/>
               </a:rPr>
-              <a:t>3–7–2 </a:t>
-            </a:r>
-            <a:r>
-              <a:rPr dirty="0" smtClean="0">
-                <a:latin typeface="Times New Roman" panose="02020603050405020304" pitchFamily="18" charset="0"/>
-                <a:cs typeface="Times New Roman" panose="02020603050405020304" pitchFamily="18" charset="0"/>
-              </a:rPr>
-              <a:t>M</a:t>
-            </a:r>
-            <a:r>
-              <a:rPr lang="en-US" dirty="0" smtClean="0">
+              <a:t>3–7–2 M</a:t>
+            </a:r>
+            <a:r>
+              <a:rPr lang="en-US" dirty="0">
                 <a:latin typeface="Times New Roman" panose="02020603050405020304" pitchFamily="18" charset="0"/>
                 <a:cs typeface="Times New Roman" panose="02020603050405020304" pitchFamily="18" charset="0"/>
               </a:rPr>
               <a:t>ulti </a:t>
             </a:r>
             <a:r>
-              <a:rPr dirty="0" smtClean="0">
+              <a:rPr dirty="0">
                 <a:latin typeface="Times New Roman" panose="02020603050405020304" pitchFamily="18" charset="0"/>
                 <a:cs typeface="Times New Roman" panose="02020603050405020304" pitchFamily="18" charset="0"/>
               </a:rPr>
               <a:t>L</a:t>
             </a:r>
             <a:r>
-              <a:rPr lang="en-US" dirty="0" smtClean="0">
-                <a:latin typeface="Times New Roman" panose="02020603050405020304" pitchFamily="18" charset="0"/>
-                <a:cs typeface="Times New Roman" panose="02020603050405020304" pitchFamily="18" charset="0"/>
-              </a:rPr>
-              <a:t>ayer Perceptron (MLP) </a:t>
-            </a:r>
-            <a:r>
-              <a:rPr lang="en-US" dirty="0">
-                <a:latin typeface="Times New Roman" panose="02020603050405020304" pitchFamily="18" charset="0"/>
-                <a:cs typeface="Times New Roman" panose="02020603050405020304" pitchFamily="18" charset="0"/>
-              </a:rPr>
-              <a:t>in </a:t>
-            </a:r>
-            <a:r>
-              <a:rPr lang="en-US" dirty="0" smtClean="0">
-                <a:latin typeface="Times New Roman" panose="02020603050405020304" pitchFamily="18" charset="0"/>
-                <a:cs typeface="Times New Roman" panose="02020603050405020304" pitchFamily="18" charset="0"/>
-              </a:rPr>
-              <a:t>Python </a:t>
-            </a:r>
-            <a:r>
-              <a:rPr lang="en-US" dirty="0">
-                <a:latin typeface="Times New Roman" panose="02020603050405020304" pitchFamily="18" charset="0"/>
-                <a:cs typeface="Times New Roman" panose="02020603050405020304" pitchFamily="18" charset="0"/>
-              </a:rPr>
-              <a:t>for training and then in VHDL for inference</a:t>
+              <a:rPr lang="en-US" dirty="0">
+                <a:latin typeface="Times New Roman" panose="02020603050405020304" pitchFamily="18" charset="0"/>
+                <a:cs typeface="Times New Roman" panose="02020603050405020304" pitchFamily="18" charset="0"/>
+              </a:rPr>
+              <a:t>ayer Perceptron (MLP) in Python for training and then in VHDL for inference</a:t>
             </a:r>
             <a:endParaRPr dirty="0">
               <a:latin typeface="Times New Roman" panose="02020603050405020304" pitchFamily="18" charset="0"/>
@@ -5654,61 +5618,50 @@
                 <a:latin typeface="Times New Roman" panose="02020603050405020304" pitchFamily="18" charset="0"/>
                 <a:cs typeface="Times New Roman" panose="02020603050405020304" pitchFamily="18" charset="0"/>
               </a:rPr>
-              <a:t>- Activation: 12-bit address -&gt; 8-bit output ROM (sigmoid </a:t>
-            </a:r>
-            <a:r>
-              <a:rPr dirty="0" smtClean="0">
-                <a:latin typeface="Times New Roman" panose="02020603050405020304" pitchFamily="18" charset="0"/>
-                <a:cs typeface="Times New Roman" panose="02020603050405020304" pitchFamily="18" charset="0"/>
-              </a:rPr>
-              <a:t>L</a:t>
-            </a:r>
-            <a:r>
-              <a:rPr lang="en-US" dirty="0" smtClean="0">
+              <a:t>- Activation: 12-bit address -&gt; 8-bit output ROM (sigmoid L</a:t>
+            </a:r>
+            <a:r>
+              <a:rPr lang="en-US" dirty="0">
                 <a:latin typeface="Times New Roman" panose="02020603050405020304" pitchFamily="18" charset="0"/>
                 <a:cs typeface="Times New Roman" panose="02020603050405020304" pitchFamily="18" charset="0"/>
               </a:rPr>
               <a:t>ook </a:t>
             </a:r>
             <a:r>
-              <a:rPr dirty="0" smtClean="0">
+              <a:rPr dirty="0">
                 <a:latin typeface="Times New Roman" panose="02020603050405020304" pitchFamily="18" charset="0"/>
                 <a:cs typeface="Times New Roman" panose="02020603050405020304" pitchFamily="18" charset="0"/>
               </a:rPr>
               <a:t>U</a:t>
             </a:r>
             <a:r>
-              <a:rPr lang="en-US" dirty="0" smtClean="0">
+              <a:rPr lang="en-US" dirty="0">
                 <a:latin typeface="Times New Roman" panose="02020603050405020304" pitchFamily="18" charset="0"/>
                 <a:cs typeface="Times New Roman" panose="02020603050405020304" pitchFamily="18" charset="0"/>
               </a:rPr>
               <a:t>p </a:t>
             </a:r>
             <a:r>
-              <a:rPr dirty="0" smtClean="0">
+              <a:rPr dirty="0">
                 <a:latin typeface="Times New Roman" panose="02020603050405020304" pitchFamily="18" charset="0"/>
                 <a:cs typeface="Times New Roman" panose="02020603050405020304" pitchFamily="18" charset="0"/>
               </a:rPr>
               <a:t>T</a:t>
             </a:r>
             <a:r>
-              <a:rPr lang="en-US" dirty="0" smtClean="0">
+              <a:rPr lang="en-US" dirty="0">
                 <a:latin typeface="Times New Roman" panose="02020603050405020304" pitchFamily="18" charset="0"/>
                 <a:cs typeface="Times New Roman" panose="02020603050405020304" pitchFamily="18" charset="0"/>
               </a:rPr>
               <a:t>able - LUT</a:t>
             </a:r>
             <a:r>
-              <a:rPr dirty="0" smtClean="0">
+              <a:rPr dirty="0">
                 <a:latin typeface="Times New Roman" panose="02020603050405020304" pitchFamily="18" charset="0"/>
                 <a:cs typeface="Times New Roman" panose="02020603050405020304" pitchFamily="18" charset="0"/>
               </a:rPr>
               <a:t>)</a:t>
             </a:r>
-            <a:endParaRPr dirty="0">
-              <a:latin typeface="Times New Roman" panose="02020603050405020304" pitchFamily="18" charset="0"/>
-              <a:cs typeface="Times New Roman" panose="02020603050405020304" pitchFamily="18" charset="0"/>
-            </a:endParaRPr>
           </a:p>
           <a:p>
             <a:r>
@@ -7606,39 +7559,11 @@
           <a:lstStyle/>
           <a:p>
             <a:r>
-              <a:rPr lang="en-US" dirty="0" smtClean="0">
-                <a:latin typeface="Times New Roman" panose="02020603050405020304" pitchFamily="18" charset="0"/>
-                <a:cs typeface="Times New Roman" panose="02020603050405020304" pitchFamily="18" charset="0"/>
-              </a:rPr>
-              <a:t>Artificial neural </a:t>
-            </a:r>
-            <a:r>
-              <a:rPr lang="en-US" dirty="0" smtClean="0">
-                <a:latin typeface="Times New Roman" panose="02020603050405020304" pitchFamily="18" charset="0"/>
-                <a:cs typeface="Times New Roman" panose="02020603050405020304" pitchFamily="18" charset="0"/>
-              </a:rPr>
-              <a:t>networks (ANNs) </a:t>
-            </a:r>
-            <a:r>
-              <a:rPr lang="en-US" dirty="0">
-                <a:latin typeface="Times New Roman" panose="02020603050405020304" pitchFamily="18" charset="0"/>
-                <a:cs typeface="Times New Roman" panose="02020603050405020304" pitchFamily="18" charset="0"/>
-              </a:rPr>
-              <a:t>are selected </a:t>
-            </a:r>
-            <a:r>
-              <a:rPr lang="en-US" dirty="0">
-                <a:latin typeface="Times New Roman" panose="02020603050405020304" pitchFamily="18" charset="0"/>
-                <a:cs typeface="Times New Roman" panose="02020603050405020304" pitchFamily="18" charset="0"/>
-              </a:rPr>
-              <a:t>for their adaptability, which enables them to analyze diverse data quickly through </a:t>
-            </a:r>
-            <a:r>
-              <a:rPr lang="en-US" dirty="0">
-                <a:latin typeface="Times New Roman" panose="02020603050405020304" pitchFamily="18" charset="0"/>
-                <a:cs typeface="Times New Roman" panose="02020603050405020304" pitchFamily="18" charset="0"/>
-              </a:rPr>
-              <a:t>network parallelism. </a:t>
+              <a:rPr lang="en-US" dirty="0">
+                <a:latin typeface="Times New Roman" panose="02020603050405020304" pitchFamily="18" charset="0"/>
+                <a:cs typeface="Times New Roman" panose="02020603050405020304" pitchFamily="18" charset="0"/>
+              </a:rPr>
+              <a:t>Artificial neural networks (ANNs) are selected for their adaptability, which enables them to analyze diverse data quickly through network parallelism. </a:t>
             </a:r>
           </a:p>
           <a:p>
@@ -7653,21 +7578,7 @@
                 <a:latin typeface="Times New Roman" panose="02020603050405020304" pitchFamily="18" charset="0"/>
                 <a:cs typeface="Times New Roman" panose="02020603050405020304" pitchFamily="18" charset="0"/>
               </a:rPr>
-              <a:t>Given these unique characteristics of ANNs, the customizable nature of </a:t>
-            </a:r>
-            <a:r>
-              <a:rPr lang="en-US" dirty="0" smtClean="0">
-                <a:latin typeface="Times New Roman" panose="02020603050405020304" pitchFamily="18" charset="0"/>
-                <a:cs typeface="Times New Roman" panose="02020603050405020304" pitchFamily="18" charset="0"/>
-              </a:rPr>
-              <a:t>FPGAs (field programmable gate arrays) </a:t>
-            </a:r>
-            <a:r>
-              <a:rPr lang="en-US" dirty="0">
-                <a:latin typeface="Times New Roman" panose="02020603050405020304" pitchFamily="18" charset="0"/>
-                <a:cs typeface="Times New Roman" panose="02020603050405020304" pitchFamily="18" charset="0"/>
-              </a:rPr>
-              <a:t>makes them an intriguing option for a hardware implementation. Therefore, even if FPGAs have poorer performance than VLSI (Very Large Scale Integration) circuits, it is still possible to change an ANN's features or structure without rebuilding the circuit. Additionally, FPGAs have rapid design cycles and are inherently parallel.</a:t>
+              <a:t>Given these unique characteristics of ANNs, the customizable nature of FPGAs (field programmable gate arrays) makes them an intriguing option for a hardware implementation. Therefore, even if FPGAs have poorer performance than VLSI (Very Large Scale Integration) circuits, it is still possible to change an ANN's features or structure without rebuilding the circuit. Additionally, FPGAs have rapid design cycles and are inherently parallel.</a:t>
             </a:r>
           </a:p>
         </p:txBody>
@@ -8330,21 +8241,6 @@
                 <a:latin typeface="Times New Roman" panose="02020603050405020304" pitchFamily="18" charset="0"/>
                 <a:cs typeface="Times New Roman" panose="02020603050405020304" pitchFamily="18" charset="0"/>
               </a:rPr>
-              <a:t> and text/COE files in </a:t>
-            </a:r>
-            <a:r>
-              <a:rPr lang="en-US" u="sng" dirty="0" err="1">
-                <a:latin typeface="Times New Roman" panose="02020603050405020304" pitchFamily="18" charset="0"/>
-                <a:cs typeface="Times New Roman" panose="02020603050405020304" pitchFamily="18" charset="0"/>
-                <a:hlinkClick r:id="rId2"/>
-              </a:rPr>
-              <a:t>coeffs</a:t>
-            </a:r>
-            <a:r>
-              <a:rPr lang="en-US" dirty="0">
-                <a:latin typeface="Times New Roman" panose="02020603050405020304" pitchFamily="18" charset="0"/>
-                <a:cs typeface="Times New Roman" panose="02020603050405020304" pitchFamily="18" charset="0"/>
-              </a:rPr>
               <a:t>:</a:t>
             </a:r>
           </a:p>
@@ -8423,20 +8319,8 @@
                 <a:latin typeface="Times New Roman" panose="02020603050405020304" pitchFamily="18" charset="0"/>
                 <a:cs typeface="Times New Roman" panose="02020603050405020304" pitchFamily="18" charset="0"/>
               </a:rPr>
-              <a:t> and </a:t>
-            </a:r>
-            <a:r>
-              <a:rPr lang="en-US" u="sng" dirty="0" err="1">
-                <a:latin typeface="Times New Roman" panose="02020603050405020304" pitchFamily="18" charset="0"/>
-                <a:cs typeface="Times New Roman" panose="02020603050405020304" pitchFamily="18" charset="0"/>
-                <a:hlinkClick r:id="rId2"/>
-              </a:rPr>
-              <a:t>activation_lut.coe</a:t>
-            </a:r>
-            <a:endParaRPr lang="en-US" dirty="0">
-              <a:latin typeface="Times New Roman" panose="02020603050405020304" pitchFamily="18" charset="0"/>
-              <a:cs typeface="Times New Roman" panose="02020603050405020304" pitchFamily="18" charset="0"/>
-            </a:endParaRPr>
+              <a:t> </a:t>
+            </a:r>
           </a:p>
           <a:p>
             <a:endParaRPr lang="en-US" sz="1600" dirty="0">
@@ -8543,7 +8427,7 @@
                 <a:latin typeface="Times New Roman" panose="02020603050405020304" pitchFamily="18" charset="0"/>
                 <a:cs typeface="Times New Roman" panose="02020603050405020304" pitchFamily="18" charset="0"/>
               </a:rPr>
-              <a:t>Compare fixed-point inference vs. floating-point using </a:t>
+              <a:t>Using </a:t>
             </a:r>
             <a:r>
               <a:rPr lang="en-US" u="sng" dirty="0">
@@ -8558,7 +8442,7 @@
                 <a:latin typeface="Times New Roman" panose="02020603050405020304" pitchFamily="18" charset="0"/>
                 <a:cs typeface="Times New Roman" panose="02020603050405020304" pitchFamily="18" charset="0"/>
               </a:rPr>
-              <a:t> and test vectors in </a:t>
+              <a:t> we test vectors in </a:t>
             </a:r>
             <a:r>
               <a:rPr lang="en-US" u="sng" dirty="0" err="1">
@@ -8575,6 +8459,15 @@
               </a:rPr>
               <a:t>.</a:t>
             </a:r>
+          </a:p>
+          <a:p>
+            <a:pPr marL="228600" lvl="1" indent="0">
+              <a:buNone/>
+            </a:pPr>
+            <a:endParaRPr lang="en-US" dirty="0">
+              <a:latin typeface="Times New Roman" panose="02020603050405020304" pitchFamily="18" charset="0"/>
+              <a:cs typeface="Times New Roman" panose="02020603050405020304" pitchFamily="18" charset="0"/>
+            </a:endParaRPr>
           </a:p>
           <a:p>
             <a:pPr lvl="0"/>
@@ -8709,103 +8602,40 @@
             </a:r>
           </a:p>
           <a:p>
+            <a:pPr marL="0" indent="0">
+              <a:buNone/>
+            </a:pPr>
+            <a:endParaRPr lang="en-US" dirty="0">
+              <a:latin typeface="Times New Roman" panose="02020603050405020304" pitchFamily="18" charset="0"/>
+              <a:cs typeface="Times New Roman" panose="02020603050405020304" pitchFamily="18" charset="0"/>
+            </a:endParaRPr>
+          </a:p>
+          <a:p>
             <a:pPr lvl="0"/>
             <a:r>
               <a:rPr lang="en-US" sz="1600" dirty="0">
                 <a:latin typeface="Times New Roman" panose="02020603050405020304" pitchFamily="18" charset="0"/>
                 <a:cs typeface="Times New Roman" panose="02020603050405020304" pitchFamily="18" charset="0"/>
               </a:rPr>
-              <a:t>Sigmoid LUT COE:</a:t>
+              <a:t>Weights/Biases:</a:t>
             </a:r>
           </a:p>
           <a:p>
             <a:pPr lvl="1"/>
             <a:r>
+              <a:rPr lang="en-US" dirty="0">
+                <a:latin typeface="Times New Roman" panose="02020603050405020304" pitchFamily="18" charset="0"/>
+                <a:cs typeface="Times New Roman" panose="02020603050405020304" pitchFamily="18" charset="0"/>
+              </a:rPr>
+              <a:t>Stored as text files in </a:t>
+            </a:r>
+            <a:r>
               <a:rPr lang="en-US" u="sng" dirty="0">
                 <a:latin typeface="Times New Roman" panose="02020603050405020304" pitchFamily="18" charset="0"/>
                 <a:cs typeface="Times New Roman" panose="02020603050405020304" pitchFamily="18" charset="0"/>
                 <a:hlinkClick r:id="rId2"/>
               </a:rPr>
-              <a:t>export_to_xilinx.py</a:t>
-            </a:r>
-            <a:r>
-              <a:rPr lang="en-US" dirty="0">
-                <a:latin typeface="Times New Roman" panose="02020603050405020304" pitchFamily="18" charset="0"/>
-                <a:cs typeface="Times New Roman" panose="02020603050405020304" pitchFamily="18" charset="0"/>
-              </a:rPr>
-              <a:t> loads </a:t>
-            </a:r>
-            <a:r>
-              <a:rPr lang="en-US" u="sng" dirty="0">
-                <a:latin typeface="Times New Roman" panose="02020603050405020304" pitchFamily="18" charset="0"/>
-                <a:cs typeface="Times New Roman" panose="02020603050405020304" pitchFamily="18" charset="0"/>
-                <a:hlinkClick r:id="rId2"/>
-              </a:rPr>
-              <a:t>activation_lut.txt</a:t>
-            </a:r>
-            <a:r>
-              <a:rPr lang="en-US" dirty="0">
-                <a:latin typeface="Times New Roman" panose="02020603050405020304" pitchFamily="18" charset="0"/>
-                <a:cs typeface="Times New Roman" panose="02020603050405020304" pitchFamily="18" charset="0"/>
-              </a:rPr>
-              <a:t> and emits </a:t>
-            </a:r>
-            <a:r>
-              <a:rPr lang="en-US" u="sng" dirty="0" err="1">
-                <a:latin typeface="Times New Roman" panose="02020603050405020304" pitchFamily="18" charset="0"/>
-                <a:cs typeface="Times New Roman" panose="02020603050405020304" pitchFamily="18" charset="0"/>
-                <a:hlinkClick r:id="rId2"/>
-              </a:rPr>
-              <a:t>activation_lut.coe</a:t>
-            </a:r>
-            <a:r>
-              <a:rPr lang="en-US" dirty="0">
-                <a:latin typeface="Times New Roman" panose="02020603050405020304" pitchFamily="18" charset="0"/>
-                <a:cs typeface="Times New Roman" panose="02020603050405020304" pitchFamily="18" charset="0"/>
-              </a:rPr>
-              <a:t> via its local function </a:t>
-            </a:r>
-            <a:r>
-              <a:rPr lang="en-US" dirty="0" err="1">
-                <a:latin typeface="Times New Roman" panose="02020603050405020304" pitchFamily="18" charset="0"/>
-                <a:cs typeface="Times New Roman" panose="02020603050405020304" pitchFamily="18" charset="0"/>
-              </a:rPr>
-              <a:t>write_coe</a:t>
-            </a:r>
-            <a:r>
-              <a:rPr lang="en-US" dirty="0">
-                <a:latin typeface="Times New Roman" panose="02020603050405020304" pitchFamily="18" charset="0"/>
-                <a:cs typeface="Times New Roman" panose="02020603050405020304" pitchFamily="18" charset="0"/>
-              </a:rPr>
-              <a:t>(...).</a:t>
-            </a:r>
-          </a:p>
-          <a:p>
-            <a:pPr lvl="0"/>
-            <a:r>
-              <a:rPr lang="en-US" sz="1600" dirty="0">
-                <a:latin typeface="Times New Roman" panose="02020603050405020304" pitchFamily="18" charset="0"/>
-                <a:cs typeface="Times New Roman" panose="02020603050405020304" pitchFamily="18" charset="0"/>
-              </a:rPr>
-              <a:t>Weights/Biases:</a:t>
-            </a:r>
-          </a:p>
-          <a:p>
-            <a:pPr lvl="1"/>
-            <a:r>
-              <a:rPr lang="en-US" dirty="0">
-                <a:latin typeface="Times New Roman" panose="02020603050405020304" pitchFamily="18" charset="0"/>
-                <a:cs typeface="Times New Roman" panose="02020603050405020304" pitchFamily="18" charset="0"/>
-              </a:rPr>
-              <a:t>Stored as text files in </a:t>
-            </a:r>
-            <a:r>
-              <a:rPr lang="en-US" u="sng" dirty="0" err="1">
-                <a:latin typeface="Times New Roman" panose="02020603050405020304" pitchFamily="18" charset="0"/>
-                <a:cs typeface="Times New Roman" panose="02020603050405020304" pitchFamily="18" charset="0"/>
-                <a:hlinkClick r:id="rId2"/>
-              </a:rPr>
-              <a:t>coeffs</a:t>
+              <a:t> artifacts</a:t>
             </a:r>
             <a:r>
               <a:rPr lang="en-US" dirty="0">
@@ -9713,22 +9543,7 @@
                 <a:latin typeface="Times New Roman" panose="02020603050405020304" pitchFamily="18" charset="0"/>
                 <a:cs typeface="Times New Roman" panose="02020603050405020304" pitchFamily="18" charset="0"/>
               </a:rPr>
-              <a:t> whose INIT is driven by </a:t>
-            </a:r>
-            <a:r>
-              <a:rPr lang="en-US" u="sng" dirty="0" err="1">
-                <a:latin typeface="Times New Roman" panose="02020603050405020304" pitchFamily="18" charset="0"/>
-                <a:cs typeface="Times New Roman" panose="02020603050405020304" pitchFamily="18" charset="0"/>
-                <a:hlinkClick r:id="rId2"/>
-              </a:rPr>
-              <a:t>activation_lut.coe</a:t>
-            </a:r>
-            <a:r>
-              <a:rPr lang="en-US" dirty="0">
-                <a:latin typeface="Times New Roman" panose="02020603050405020304" pitchFamily="18" charset="0"/>
-                <a:cs typeface="Times New Roman" panose="02020603050405020304" pitchFamily="18" charset="0"/>
-              </a:rPr>
-              <a:t>.</a:t>
+              <a:t> .</a:t>
             </a:r>
           </a:p>
           <a:p>
@@ -9808,14 +9623,14 @@
           <a:p>
             <a:pPr lvl="0"/>
             <a:r>
-              <a:rPr lang="en-US" sz="1600" u="sng" dirty="0" smtClean="0">
+              <a:rPr lang="en-US" sz="1600" u="sng" dirty="0">
                 <a:latin typeface="Times New Roman" panose="02020603050405020304" pitchFamily="18" charset="0"/>
                 <a:cs typeface="Times New Roman" panose="02020603050405020304" pitchFamily="18" charset="0"/>
                 <a:hlinkClick r:id="rId2"/>
               </a:rPr>
               <a:t>control</a:t>
             </a:r>
-            <a:endParaRPr lang="en-US" sz="1600" dirty="0" smtClean="0">
+            <a:endParaRPr lang="en-US" sz="1600" dirty="0">
               <a:latin typeface="Times New Roman" panose="02020603050405020304" pitchFamily="18" charset="0"/>
               <a:cs typeface="Times New Roman" panose="02020603050405020304" pitchFamily="18" charset="0"/>
             </a:endParaRPr>
@@ -9823,7 +9638,7 @@
           <a:p>
             <a:pPr lvl="1"/>
             <a:r>
-              <a:rPr lang="en-US" dirty="0" smtClean="0">
+              <a:rPr lang="en-US" dirty="0">
                 <a:latin typeface="Times New Roman" panose="02020603050405020304" pitchFamily="18" charset="0"/>
                 <a:cs typeface="Times New Roman" panose="02020603050405020304" pitchFamily="18" charset="0"/>
               </a:rPr>
@@ -9833,7 +9648,7 @@
           <a:p>
             <a:pPr lvl="2"/>
             <a:r>
-              <a:rPr lang="en-US" dirty="0" smtClean="0">
+              <a:rPr lang="en-US" dirty="0">
                 <a:latin typeface="Times New Roman" panose="02020603050405020304" pitchFamily="18" charset="0"/>
                 <a:cs typeface="Times New Roman" panose="02020603050405020304" pitchFamily="18" charset="0"/>
               </a:rPr>
@@ -9843,7 +9658,7 @@
           <a:p>
             <a:pPr lvl="2"/>
             <a:r>
-              <a:rPr lang="en-US" dirty="0" smtClean="0">
+              <a:rPr lang="en-US" dirty="0">
                 <a:latin typeface="Times New Roman" panose="02020603050405020304" pitchFamily="18" charset="0"/>
                 <a:cs typeface="Times New Roman" panose="02020603050405020304" pitchFamily="18" charset="0"/>
               </a:rPr>
@@ -9853,7 +9668,7 @@
           <a:p>
             <a:pPr lvl="2"/>
             <a:r>
-              <a:rPr lang="en-US" dirty="0" smtClean="0">
+              <a:rPr lang="en-US" dirty="0">
                 <a:latin typeface="Times New Roman" panose="02020603050405020304" pitchFamily="18" charset="0"/>
                 <a:cs typeface="Times New Roman" panose="02020603050405020304" pitchFamily="18" charset="0"/>
               </a:rPr>
@@ -9863,7 +9678,7 @@
           <a:p>
             <a:pPr lvl="2"/>
             <a:r>
-              <a:rPr lang="en-US" dirty="0" smtClean="0">
+              <a:rPr lang="en-US" dirty="0">
                 <a:latin typeface="Times New Roman" panose="02020603050405020304" pitchFamily="18" charset="0"/>
                 <a:cs typeface="Times New Roman" panose="02020603050405020304" pitchFamily="18" charset="0"/>
               </a:rPr>
@@ -9873,7 +9688,7 @@
           <a:p>
             <a:pPr lvl="1"/>
             <a:r>
-              <a:rPr lang="en-US" dirty="0" smtClean="0">
+              <a:rPr lang="en-US" dirty="0">
                 <a:latin typeface="Times New Roman" panose="02020603050405020304" pitchFamily="18" charset="0"/>
                 <a:cs typeface="Times New Roman" panose="02020603050405020304" pitchFamily="18" charset="0"/>
               </a:rPr>
@@ -9959,7 +9774,7 @@
                 <a:latin typeface="Times New Roman" panose="02020603050405020304" pitchFamily="18" charset="0"/>
                 <a:cs typeface="Times New Roman" panose="02020603050405020304" pitchFamily="18" charset="0"/>
               </a:rPr>
-              <a:t>Purpose: top-level; instantiates control + arrays of neurons for each layer + sigmoid IP; wires constants from </a:t>
+              <a:t>Purpose: top-level entity; instantiates control + arrays of neurons for each layer + sigmoid IP; wires constants from </a:t>
             </a:r>
             <a:r>
               <a:rPr lang="en-US" u="sng" dirty="0" err="1">
@@ -9998,14 +9813,7 @@
                 <a:latin typeface="Times New Roman" panose="02020603050405020304" pitchFamily="18" charset="0"/>
                 <a:cs typeface="Times New Roman" panose="02020603050405020304" pitchFamily="18" charset="0"/>
               </a:rPr>
-              <a:t> TCL scripts</a:t>
-            </a:r>
-            <a:r>
-              <a:rPr lang="en-US" dirty="0" smtClean="0">
-                <a:latin typeface="Times New Roman" panose="02020603050405020304" pitchFamily="18" charset="0"/>
-                <a:cs typeface="Times New Roman" panose="02020603050405020304" pitchFamily="18" charset="0"/>
-              </a:rPr>
-              <a:t>.</a:t>
+              <a:t> TCL scripts.</a:t>
             </a:r>
           </a:p>
           <a:p>
@@ -10495,21 +10303,7 @@
                 <a:latin typeface="Times New Roman" panose="02020603050405020304" pitchFamily="18" charset="0"/>
                 <a:cs typeface="Times New Roman" panose="02020603050405020304" pitchFamily="18" charset="0"/>
               </a:rPr>
-              <a:t> samples are registered and forwarded as </a:t>
-            </a:r>
-            <a:r>
-              <a:rPr lang="en-US" dirty="0" smtClean="0">
-                <a:latin typeface="Times New Roman" panose="02020603050405020304" pitchFamily="18" charset="0"/>
-                <a:cs typeface="Times New Roman" panose="02020603050405020304" pitchFamily="18" charset="0"/>
-              </a:rPr>
-              <a:t>feature inputs to the first-layer </a:t>
-            </a:r>
-            <a:r>
-              <a:rPr lang="en-US" dirty="0">
-                <a:latin typeface="Times New Roman" panose="02020603050405020304" pitchFamily="18" charset="0"/>
-                <a:cs typeface="Times New Roman" panose="02020603050405020304" pitchFamily="18" charset="0"/>
-              </a:rPr>
-              <a:t>MACs.</a:t>
+              <a:t> samples are registered and forwarded as feature inputs to the first-layer MACs.</a:t>
             </a:r>
           </a:p>
           <a:p>
@@ -10606,14 +10400,7 @@
                 <a:latin typeface="Times New Roman" panose="02020603050405020304" pitchFamily="18" charset="0"/>
                 <a:cs typeface="Times New Roman" panose="02020603050405020304" pitchFamily="18" charset="0"/>
               </a:rPr>
-              <a:t>Compute</a:t>
-            </a:r>
-            <a:r>
-              <a:rPr lang="en-US" dirty="0" smtClean="0">
-                <a:latin typeface="Times New Roman" panose="02020603050405020304" pitchFamily="18" charset="0"/>
-                <a:cs typeface="Times New Roman" panose="02020603050405020304" pitchFamily="18" charset="0"/>
-              </a:rPr>
-              <a:t>:</a:t>
+              <a:t>Compute:</a:t>
             </a:r>
           </a:p>
           <a:p>
@@ -10671,10 +10458,10 @@
                 <a:latin typeface="Times New Roman" panose="02020603050405020304" pitchFamily="18" charset="0"/>
                 <a:cs typeface="Times New Roman" panose="02020603050405020304" pitchFamily="18" charset="0"/>
               </a:rPr>
-              <a:t>activation_lut.coe</a:t>
-            </a:r>
-            <a:r>
-              <a:rPr lang="en-US" dirty="0" smtClean="0">
+              <a:t>coe</a:t>
+            </a:r>
+            <a:r>
+              <a:rPr lang="en-US" dirty="0">
                 <a:latin typeface="Times New Roman" panose="02020603050405020304" pitchFamily="18" charset="0"/>
                 <a:cs typeface="Times New Roman" panose="02020603050405020304" pitchFamily="18" charset="0"/>
               </a:rPr>
@@ -10706,25 +10493,18 @@
               <a:t>Fixed‑point scaling follows the project’s </a:t>
             </a:r>
             <a:r>
-              <a:rPr lang="en-US" dirty="0" err="1" smtClean="0">
+              <a:rPr lang="en-US" dirty="0" err="1">
                 <a:latin typeface="Times New Roman" panose="02020603050405020304" pitchFamily="18" charset="0"/>
                 <a:cs typeface="Times New Roman" panose="02020603050405020304" pitchFamily="18" charset="0"/>
               </a:rPr>
               <a:t>Qm.n</a:t>
             </a:r>
             <a:r>
-              <a:rPr lang="en-US" dirty="0" smtClean="0">
-                <a:latin typeface="Times New Roman" panose="02020603050405020304" pitchFamily="18" charset="0"/>
-                <a:cs typeface="Times New Roman" panose="02020603050405020304" pitchFamily="18" charset="0"/>
-              </a:rPr>
-              <a:t> </a:t>
-            </a:r>
-            <a:r>
-              <a:rPr lang="en-US" dirty="0">
-                <a:latin typeface="Times New Roman" panose="02020603050405020304" pitchFamily="18" charset="0"/>
-                <a:cs typeface="Times New Roman" panose="02020603050405020304" pitchFamily="18" charset="0"/>
-              </a:rPr>
-              <a:t>settings from </a:t>
+              <a:rPr lang="en-US" dirty="0">
+                <a:latin typeface="Times New Roman" panose="02020603050405020304" pitchFamily="18" charset="0"/>
+                <a:cs typeface="Times New Roman" panose="02020603050405020304" pitchFamily="18" charset="0"/>
+              </a:rPr>
+              <a:t> settings from </a:t>
             </a:r>
             <a:r>
               <a:rPr lang="en-US" dirty="0" err="1">
@@ -10738,21 +10518,7 @@
                 <a:latin typeface="Times New Roman" panose="02020603050405020304" pitchFamily="18" charset="0"/>
                 <a:cs typeface="Times New Roman" panose="02020603050405020304" pitchFamily="18" charset="0"/>
               </a:rPr>
-              <a:t> (inputs are interpreted in that format; arithmetic is scaled by </a:t>
-            </a:r>
-            <a:r>
-              <a:rPr lang="en-US" dirty="0" smtClean="0">
-                <a:latin typeface="Times New Roman" panose="02020603050405020304" pitchFamily="18" charset="0"/>
-                <a:cs typeface="Times New Roman" panose="02020603050405020304" pitchFamily="18" charset="0"/>
-              </a:rPr>
-              <a:t>the </a:t>
-            </a:r>
-            <a:r>
-              <a:rPr lang="en-US" dirty="0">
-                <a:latin typeface="Times New Roman" panose="02020603050405020304" pitchFamily="18" charset="0"/>
-                <a:cs typeface="Times New Roman" panose="02020603050405020304" pitchFamily="18" charset="0"/>
-              </a:rPr>
-              <a:t>NN result is mapped to </a:t>
+              <a:t> (inputs are interpreted in that format; arithmetic is scaled by the NN result is mapped to </a:t>
             </a:r>
             <a:r>
               <a:rPr lang="en-US" dirty="0" err="1">
@@ -10914,66 +10680,20 @@
           <a:lstStyle/>
           <a:p>
             <a:r>
-              <a:rPr lang="en-US" dirty="0" smtClean="0">
-                <a:latin typeface="Times New Roman" panose="02020603050405020304" pitchFamily="18" charset="0"/>
-                <a:cs typeface="Times New Roman" panose="02020603050405020304" pitchFamily="18" charset="0"/>
-              </a:rPr>
-              <a:t>The problem </a:t>
-            </a:r>
-            <a:r>
-              <a:rPr lang="en-US" dirty="0">
-                <a:latin typeface="Times New Roman" panose="02020603050405020304" pitchFamily="18" charset="0"/>
-                <a:cs typeface="Times New Roman" panose="02020603050405020304" pitchFamily="18" charset="0"/>
-              </a:rPr>
-              <a:t>of real-time wildfire indication </a:t>
-            </a:r>
-            <a:r>
-              <a:rPr lang="en-US" dirty="0" smtClean="0">
-                <a:latin typeface="Times New Roman" panose="02020603050405020304" pitchFamily="18" charset="0"/>
-                <a:cs typeface="Times New Roman" panose="02020603050405020304" pitchFamily="18" charset="0"/>
-              </a:rPr>
-              <a:t>by using </a:t>
-            </a:r>
-            <a:r>
-              <a:rPr lang="en-US" dirty="0">
-                <a:latin typeface="Times New Roman" panose="02020603050405020304" pitchFamily="18" charset="0"/>
-                <a:cs typeface="Times New Roman" panose="02020603050405020304" pitchFamily="18" charset="0"/>
-              </a:rPr>
-              <a:t>RGB video streams, with per-pixel classification performed at full video frame rate. The system is designed to operate entirely at the edge, without relying on cloud infrastructure or </a:t>
-            </a:r>
-            <a:r>
-              <a:rPr lang="en-US" dirty="0" smtClean="0">
-                <a:latin typeface="Times New Roman" panose="02020603050405020304" pitchFamily="18" charset="0"/>
-                <a:cs typeface="Times New Roman" panose="02020603050405020304" pitchFamily="18" charset="0"/>
-              </a:rPr>
-              <a:t>GPU (Graphical Processing Unit) </a:t>
-            </a:r>
-            <a:r>
-              <a:rPr lang="en-US" dirty="0">
-                <a:latin typeface="Times New Roman" panose="02020603050405020304" pitchFamily="18" charset="0"/>
-                <a:cs typeface="Times New Roman" panose="02020603050405020304" pitchFamily="18" charset="0"/>
-              </a:rPr>
-              <a:t>acceleration. </a:t>
-            </a:r>
-            <a:endParaRPr lang="en-US" dirty="0" smtClean="0">
-              <a:latin typeface="Times New Roman" panose="02020603050405020304" pitchFamily="18" charset="0"/>
-              <a:cs typeface="Times New Roman" panose="02020603050405020304" pitchFamily="18" charset="0"/>
-            </a:endParaRPr>
-          </a:p>
-          <a:p>
-            <a:r>
-              <a:rPr lang="en-US" dirty="0" smtClean="0">
-                <a:latin typeface="Times New Roman" panose="02020603050405020304" pitchFamily="18" charset="0"/>
-                <a:cs typeface="Times New Roman" panose="02020603050405020304" pitchFamily="18" charset="0"/>
-              </a:rPr>
-              <a:t>The </a:t>
-            </a:r>
-            <a:r>
-              <a:rPr lang="en-US" dirty="0">
-                <a:latin typeface="Times New Roman" panose="02020603050405020304" pitchFamily="18" charset="0"/>
-                <a:cs typeface="Times New Roman" panose="02020603050405020304" pitchFamily="18" charset="0"/>
-              </a:rPr>
-              <a:t>overall goal is to achieve high throughput with low power consumption, enabling reliable and responsive wildfire detection in practical deployments.</a:t>
+              <a:rPr lang="en-US" dirty="0">
+                <a:latin typeface="Times New Roman" panose="02020603050405020304" pitchFamily="18" charset="0"/>
+                <a:cs typeface="Times New Roman" panose="02020603050405020304" pitchFamily="18" charset="0"/>
+              </a:rPr>
+              <a:t>The problem of real-time wildfire indication by using RGB video streams, with per-pixel classification performed at full video frame rate. The system is designed to operate entirely at the edge, without relying on cloud infrastructure or GPU (Graphical Processing Unit) acceleration. </a:t>
+            </a:r>
+          </a:p>
+          <a:p>
+            <a:r>
+              <a:rPr lang="en-US" dirty="0">
+                <a:latin typeface="Times New Roman" panose="02020603050405020304" pitchFamily="18" charset="0"/>
+                <a:cs typeface="Times New Roman" panose="02020603050405020304" pitchFamily="18" charset="0"/>
+              </a:rPr>
+              <a:t>The overall goal is to achieve high throughput with low power consumption, enabling reliable and responsive wildfire detection in practical deployments.</a:t>
             </a:r>
             <a:endParaRPr dirty="0">
               <a:latin typeface="Times New Roman" panose="02020603050405020304" pitchFamily="18" charset="0"/>
@@ -11024,7 +10744,7 @@
         </p:nvSpPr>
         <p:spPr>
           <a:xfrm>
-            <a:off x="1606045" y="208410"/>
+            <a:off x="1606045" y="925586"/>
             <a:ext cx="5937755" cy="1188720"/>
           </a:xfrm>
         </p:spPr>
@@ -11039,121 +10759,319 @@
           </a:p>
         </p:txBody>
       </p:sp>
-      <p:pic>
-        <p:nvPicPr>
-          <p:cNvPr id="6" name="Content Placeholder 5"/>
-          <p:cNvPicPr>
-            <a:picLocks noGrp="1" noChangeAspect="1"/>
-          </p:cNvPicPr>
+      <p:graphicFrame>
+        <p:nvGraphicFramePr>
+          <p:cNvPr id="9" name="Table 8"/>
+          <p:cNvGraphicFramePr>
+            <a:graphicFrameLocks noGrp="1"/>
+          </p:cNvGraphicFramePr>
           <p:nvPr>
-            <p:ph idx="1"/>
+            <p:extLst>
+              <p:ext uri="{D42A27DB-BD31-4B8C-83A1-F6EECF244321}">
+                <p14:modId xmlns:p14="http://schemas.microsoft.com/office/powerpoint/2010/main" val="3702850429"/>
+              </p:ext>
+            </p:extLst>
           </p:nvPr>
-        </p:nvPicPr>
-        <p:blipFill rotWithShape="1">
-          <a:blip r:embed="rId2">
-            <a:extLst>
-              <a:ext uri="{28A0092B-C50C-407E-A947-70E740481C1C}">
-                <a14:useLocalDpi xmlns:a14="http://schemas.microsoft.com/office/drawing/2010/main" val="0"/>
-              </a:ext>
-            </a:extLst>
-          </a:blip>
-          <a:srcRect l="23427" r="45477"/>
-          <a:stretch/>
-        </p:blipFill>
-        <p:spPr>
-          <a:xfrm>
-            <a:off x="0" y="4385052"/>
-            <a:ext cx="4435008" cy="678267"/>
-          </a:xfrm>
-        </p:spPr>
-      </p:pic>
-      <p:pic>
-        <p:nvPicPr>
-          <p:cNvPr id="8" name="Picture 7"/>
-          <p:cNvPicPr>
-            <a:picLocks noChangeAspect="1"/>
-          </p:cNvPicPr>
-          <p:nvPr/>
-        </p:nvPicPr>
-        <p:blipFill rotWithShape="1">
-          <a:blip r:embed="rId3">
-            <a:extLst>
-              <a:ext uri="{28A0092B-C50C-407E-A947-70E740481C1C}">
-                <a14:useLocalDpi xmlns:a14="http://schemas.microsoft.com/office/drawing/2010/main" val="0"/>
-              </a:ext>
-            </a:extLst>
-          </a:blip>
-          <a:srcRect l="13236" t="40344" r="37548" b="21940"/>
-          <a:stretch/>
-        </p:blipFill>
-        <p:spPr>
-          <a:xfrm>
-            <a:off x="0" y="1459883"/>
-            <a:ext cx="6691880" cy="2906036"/>
-          </a:xfrm>
-          <a:prstGeom prst="rect">
-            <a:avLst/>
-          </a:prstGeom>
-        </p:spPr>
-      </p:pic>
-      <p:pic>
-        <p:nvPicPr>
-          <p:cNvPr id="3" name="Picture 2"/>
-          <p:cNvPicPr>
-            <a:picLocks noChangeAspect="1"/>
-          </p:cNvPicPr>
-          <p:nvPr/>
-        </p:nvPicPr>
-        <p:blipFill rotWithShape="1">
-          <a:blip r:embed="rId4">
-            <a:extLst>
-              <a:ext uri="{28A0092B-C50C-407E-A947-70E740481C1C}">
-                <a14:useLocalDpi xmlns:a14="http://schemas.microsoft.com/office/drawing/2010/main" val="0"/>
-              </a:ext>
-            </a:extLst>
-          </a:blip>
-          <a:srcRect l="13137" t="39506" r="50294" b="45577"/>
-          <a:stretch/>
-        </p:blipFill>
-        <p:spPr>
-          <a:xfrm>
-            <a:off x="0" y="5063319"/>
-            <a:ext cx="5987789" cy="1380565"/>
-          </a:xfrm>
-          <a:prstGeom prst="rect">
-            <a:avLst/>
-          </a:prstGeom>
-        </p:spPr>
-      </p:pic>
-      <p:pic>
-        <p:nvPicPr>
-          <p:cNvPr id="4" name="Picture 3"/>
-          <p:cNvPicPr>
-            <a:picLocks noChangeAspect="1"/>
-          </p:cNvPicPr>
-          <p:nvPr/>
-        </p:nvPicPr>
-        <p:blipFill rotWithShape="1">
-          <a:blip r:embed="rId2">
-            <a:extLst>
-              <a:ext uri="{28A0092B-C50C-407E-A947-70E740481C1C}">
-                <a14:useLocalDpi xmlns:a14="http://schemas.microsoft.com/office/drawing/2010/main" val="0"/>
-              </a:ext>
-            </a:extLst>
-          </a:blip>
-          <a:srcRect l="73235" t="1" r="11667" b="-6693"/>
-          <a:stretch/>
-        </p:blipFill>
-        <p:spPr>
-          <a:xfrm>
-            <a:off x="4435008" y="3856058"/>
-            <a:ext cx="3779069" cy="1270014"/>
-          </a:xfrm>
-          <a:prstGeom prst="rect">
-            <a:avLst/>
-          </a:prstGeom>
-        </p:spPr>
-      </p:pic>
+        </p:nvGraphicFramePr>
+        <p:xfrm>
+          <a:off x="361510" y="2772505"/>
+          <a:ext cx="8426824" cy="1944188"/>
+        </p:xfrm>
+        <a:graphic>
+          <a:graphicData uri="http://schemas.openxmlformats.org/drawingml/2006/table">
+            <a:tbl>
+              <a:tblPr firstRow="1" bandRow="1">
+                <a:tableStyleId>{5C22544A-7EE6-4342-B048-85BDC9FD1C3A}</a:tableStyleId>
+              </a:tblPr>
+              <a:tblGrid>
+                <a:gridCol w="1102659">
+                  <a:extLst>
+                    <a:ext uri="{9D8B030D-6E8A-4147-A177-3AD203B41FA5}">
+                      <a16:colId xmlns:a16="http://schemas.microsoft.com/office/drawing/2014/main" val="2160701451"/>
+                    </a:ext>
+                  </a:extLst>
+                </a:gridCol>
+                <a:gridCol w="1129553">
+                  <a:extLst>
+                    <a:ext uri="{9D8B030D-6E8A-4147-A177-3AD203B41FA5}">
+                      <a16:colId xmlns:a16="http://schemas.microsoft.com/office/drawing/2014/main" val="3202040930"/>
+                    </a:ext>
+                  </a:extLst>
+                </a:gridCol>
+                <a:gridCol w="968189">
+                  <a:extLst>
+                    <a:ext uri="{9D8B030D-6E8A-4147-A177-3AD203B41FA5}">
+                      <a16:colId xmlns:a16="http://schemas.microsoft.com/office/drawing/2014/main" val="2819133894"/>
+                    </a:ext>
+                  </a:extLst>
+                </a:gridCol>
+                <a:gridCol w="1614927">
+                  <a:extLst>
+                    <a:ext uri="{9D8B030D-6E8A-4147-A177-3AD203B41FA5}">
+                      <a16:colId xmlns:a16="http://schemas.microsoft.com/office/drawing/2014/main" val="1512091898"/>
+                    </a:ext>
+                  </a:extLst>
+                </a:gridCol>
+                <a:gridCol w="1594437">
+                  <a:extLst>
+                    <a:ext uri="{9D8B030D-6E8A-4147-A177-3AD203B41FA5}">
+                      <a16:colId xmlns:a16="http://schemas.microsoft.com/office/drawing/2014/main" val="1876332834"/>
+                    </a:ext>
+                  </a:extLst>
+                </a:gridCol>
+                <a:gridCol w="813227">
+                  <a:extLst>
+                    <a:ext uri="{9D8B030D-6E8A-4147-A177-3AD203B41FA5}">
+                      <a16:colId xmlns:a16="http://schemas.microsoft.com/office/drawing/2014/main" val="3494988610"/>
+                    </a:ext>
+                  </a:extLst>
+                </a:gridCol>
+                <a:gridCol w="1203832">
+                  <a:extLst>
+                    <a:ext uri="{9D8B030D-6E8A-4147-A177-3AD203B41FA5}">
+                      <a16:colId xmlns:a16="http://schemas.microsoft.com/office/drawing/2014/main" val="3519566896"/>
+                    </a:ext>
+                  </a:extLst>
+                </a:gridCol>
+              </a:tblGrid>
+              <a:tr h="1140013">
+                <a:tc>
+                  <a:txBody>
+                    <a:bodyPr/>
+                    <a:lstStyle/>
+                    <a:p>
+                      <a:pPr algn="l"/>
+                      <a:r>
+                        <a:rPr lang="en-US" dirty="0"/>
+                        <a:t>Board</a:t>
+                      </a:r>
+                    </a:p>
+                  </a:txBody>
+                  <a:tcPr/>
+                </a:tc>
+                <a:tc>
+                  <a:txBody>
+                    <a:bodyPr/>
+                    <a:lstStyle/>
+                    <a:p>
+                      <a:pPr algn="l"/>
+                      <a:r>
+                        <a:rPr lang="en-US"/>
+                        <a:t>f (MHz)</a:t>
+                      </a:r>
+                    </a:p>
+                  </a:txBody>
+                  <a:tcPr/>
+                </a:tc>
+                <a:tc>
+                  <a:txBody>
+                    <a:bodyPr/>
+                    <a:lstStyle/>
+                    <a:p>
+                      <a:pPr algn="l"/>
+                      <a:r>
+                        <a:rPr lang="en-US"/>
+                        <a:t>Area (LUT)</a:t>
+                      </a:r>
+                    </a:p>
+                  </a:txBody>
+                  <a:tcPr/>
+                </a:tc>
+                <a:tc>
+                  <a:txBody>
+                    <a:bodyPr/>
+                    <a:lstStyle/>
+                    <a:p>
+                      <a:pPr algn="l"/>
+                      <a:r>
+                        <a:rPr lang="en-US" dirty="0"/>
+                        <a:t>Throughput (</a:t>
+                      </a:r>
+                      <a:r>
+                        <a:rPr lang="en-US" dirty="0" err="1"/>
+                        <a:t>Gbps</a:t>
+                      </a:r>
+                      <a:r>
+                        <a:rPr lang="en-US" dirty="0"/>
+                        <a:t>)</a:t>
+                      </a:r>
+                    </a:p>
+                  </a:txBody>
+                  <a:tcPr/>
+                </a:tc>
+                <a:tc>
+                  <a:txBody>
+                    <a:bodyPr/>
+                    <a:lstStyle/>
+                    <a:p>
+                      <a:pPr algn="l"/>
+                      <a:r>
+                        <a:rPr lang="en-US" dirty="0"/>
+                        <a:t>Throughput/area (</a:t>
+                      </a:r>
+                      <a:r>
+                        <a:rPr lang="en-US" dirty="0" err="1"/>
+                        <a:t>Gbps</a:t>
+                      </a:r>
+                      <a:r>
+                        <a:rPr lang="en-US" dirty="0"/>
+                        <a:t>/</a:t>
+                      </a:r>
+                      <a:r>
+                        <a:rPr lang="en-US" dirty="0" err="1"/>
+                        <a:t>kLUT</a:t>
+                      </a:r>
+                      <a:r>
+                        <a:rPr lang="en-US" dirty="0"/>
+                        <a:t>)</a:t>
+                      </a:r>
+                    </a:p>
+                  </a:txBody>
+                  <a:tcPr/>
+                </a:tc>
+                <a:tc>
+                  <a:txBody>
+                    <a:bodyPr/>
+                    <a:lstStyle/>
+                    <a:p>
+                      <a:pPr algn="l"/>
+                      <a:r>
+                        <a:rPr lang="en-US"/>
+                        <a:t>CLB</a:t>
+                      </a:r>
+                    </a:p>
+                  </a:txBody>
+                  <a:tcPr/>
+                </a:tc>
+                <a:tc>
+                  <a:txBody>
+                    <a:bodyPr/>
+                    <a:lstStyle/>
+                    <a:p>
+                      <a:pPr algn="l"/>
+                      <a:r>
+                        <a:rPr lang="en-US"/>
+                        <a:t>Slice</a:t>
+                      </a:r>
+                    </a:p>
+                  </a:txBody>
+                  <a:tcPr/>
+                </a:tc>
+                <a:extLst>
+                  <a:ext uri="{0D108BD9-81ED-4DB2-BD59-A6C34878D82A}">
+                    <a16:rowId xmlns:a16="http://schemas.microsoft.com/office/drawing/2014/main" val="741427603"/>
+                  </a:ext>
+                </a:extLst>
+              </a:tr>
+              <a:tr h="804175">
+                <a:tc>
+                  <a:txBody>
+                    <a:bodyPr/>
+                    <a:lstStyle/>
+                    <a:p>
+                      <a:pPr algn="l"/>
+                      <a:r>
+                        <a:rPr lang="en-US"/>
+                        <a:t>ZCU106</a:t>
+                      </a:r>
+                    </a:p>
+                  </a:txBody>
+                  <a:tcPr/>
+                </a:tc>
+                <a:tc>
+                  <a:txBody>
+                    <a:bodyPr/>
+                    <a:lstStyle/>
+                    <a:p>
+                      <a:pPr algn="l"/>
+                      <a:r>
+                        <a:rPr lang="en-CY"/>
+                        <a:t>74.25</a:t>
+                      </a:r>
+                    </a:p>
+                  </a:txBody>
+                  <a:tcPr/>
+                </a:tc>
+                <a:tc>
+                  <a:txBody>
+                    <a:bodyPr/>
+                    <a:lstStyle/>
+                    <a:p>
+                      <a:pPr algn="l"/>
+                      <a:r>
+                        <a:rPr lang="en-CY"/>
+                        <a:t>4850</a:t>
+                      </a:r>
+                    </a:p>
+                  </a:txBody>
+                  <a:tcPr/>
+                </a:tc>
+                <a:tc>
+                  <a:txBody>
+                    <a:bodyPr/>
+                    <a:lstStyle/>
+                    <a:p>
+                      <a:pPr algn="l"/>
+                      <a:r>
+                        <a:rPr lang="en-CY"/>
+                        <a:t>1.782</a:t>
+                      </a:r>
+                    </a:p>
+                  </a:txBody>
+                  <a:tcPr/>
+                </a:tc>
+                <a:tc>
+                  <a:txBody>
+                    <a:bodyPr/>
+                    <a:lstStyle/>
+                    <a:p>
+                      <a:pPr algn="l"/>
+                      <a:r>
+                        <a:rPr lang="en-CY"/>
+                        <a:t>0.367</a:t>
+                      </a:r>
+                    </a:p>
+                  </a:txBody>
+                  <a:tcPr/>
+                </a:tc>
+                <a:tc>
+                  <a:txBody>
+                    <a:bodyPr/>
+                    <a:lstStyle/>
+                    <a:p>
+                      <a:pPr algn="l"/>
+                      <a:r>
+                        <a:rPr lang="en-CY"/>
+                        <a:t>≈304</a:t>
+                      </a:r>
+                    </a:p>
+                  </a:txBody>
+                  <a:tcPr/>
+                </a:tc>
+                <a:tc>
+                  <a:txBody>
+                    <a:bodyPr/>
+                    <a:lstStyle/>
+                    <a:p>
+                      <a:pPr algn="l"/>
+                      <a:r>
+                        <a:rPr lang="en-CY" dirty="0"/>
+                        <a:t>≈607</a:t>
+                      </a:r>
+                    </a:p>
+                  </a:txBody>
+                  <a:tcPr/>
+                </a:tc>
+                <a:extLst>
+                  <a:ext uri="{0D108BD9-81ED-4DB2-BD59-A6C34878D82A}">
+                    <a16:rowId xmlns:a16="http://schemas.microsoft.com/office/drawing/2014/main" val="656657113"/>
+                  </a:ext>
+                </a:extLst>
+              </a:tr>
+            </a:tbl>
+          </a:graphicData>
+        </a:graphic>
+      </p:graphicFrame>
     </p:spTree>
   </p:cSld>
   <p:clrMapOvr>
@@ -11225,14 +11143,7 @@
                 <a:latin typeface="Times New Roman" panose="02020603050405020304" pitchFamily="18" charset="0"/>
                 <a:cs typeface="Times New Roman" panose="02020603050405020304" pitchFamily="18" charset="0"/>
               </a:rPr>
-              <a:t>Training and inference on a single device without software is limited, despite the flexibility and inheritance of parallelism on FPGAs. The backpropagation modules and data chain can be implemented in terms of area and resource usage</a:t>
-            </a:r>
-            <a:r>
-              <a:rPr lang="en-US" dirty="0" smtClean="0">
-                <a:latin typeface="Times New Roman" panose="02020603050405020304" pitchFamily="18" charset="0"/>
-                <a:cs typeface="Times New Roman" panose="02020603050405020304" pitchFamily="18" charset="0"/>
-              </a:rPr>
-              <a:t>.</a:t>
+              <a:t>Training and inference on a single device without software is limited, despite the flexibility and inheritance of parallelism on FPGAs. The backpropagation modules and data chain can be implemented in terms of area and resource usage.</a:t>
             </a:r>
           </a:p>
           <a:p>
@@ -11610,7 +11521,7 @@
         <p:spPr>
           <a:xfrm>
             <a:off x="475129" y="1066801"/>
-            <a:ext cx="6786283" cy="3816429"/>
+            <a:ext cx="6786283" cy="3570208"/>
           </a:xfrm>
           <a:prstGeom prst="rect">
             <a:avLst/>
@@ -11652,9 +11563,6 @@
             </a:endParaRPr>
           </a:p>
           <a:p>
-            <a:pPr marL="342900" indent="-342900">
-              <a:buAutoNum type="arabicPeriod"/>
-            </a:pPr>
             <a:r>
               <a:rPr lang="en-US" sz="1600" dirty="0">
                 <a:latin typeface="Times New Roman" panose="02020603050405020304" pitchFamily="18" charset="0"/>
@@ -11949,25 +11857,18 @@
               <a:t>2. Activation: The result of the linear transformation (denoted as z) is then passed through an activation function. The activation function is crucial because it introduces non-linearity into the system, enabling the network to learn more complex patterns. Popular activation functions include </a:t>
             </a:r>
             <a:r>
-              <a:rPr lang="en-US" sz="1600" dirty="0" err="1" smtClean="0">
+              <a:rPr lang="en-US" sz="1600" dirty="0" err="1">
                 <a:latin typeface="Times New Roman" panose="02020603050405020304" pitchFamily="18" charset="0"/>
                 <a:cs typeface="Times New Roman" panose="02020603050405020304" pitchFamily="18" charset="0"/>
               </a:rPr>
               <a:t>ReLU</a:t>
             </a:r>
             <a:r>
-              <a:rPr lang="en-US" sz="1600" dirty="0" smtClean="0">
-                <a:latin typeface="Times New Roman" panose="02020603050405020304" pitchFamily="18" charset="0"/>
-                <a:cs typeface="Times New Roman" panose="02020603050405020304" pitchFamily="18" charset="0"/>
-              </a:rPr>
-              <a:t> (Rectified Linear Unit) </a:t>
-            </a:r>
-            <a:r>
               <a:rPr lang="en-US" sz="1600" dirty="0">
                 <a:latin typeface="Times New Roman" panose="02020603050405020304" pitchFamily="18" charset="0"/>
                 <a:cs typeface="Times New Roman" panose="02020603050405020304" pitchFamily="18" charset="0"/>
               </a:rPr>
-              <a:t>and sigmoid.</a:t>
+              <a:t> (Rectified Linear Unit) and sigmoid.</a:t>
             </a:r>
           </a:p>
         </p:txBody>
@@ -12054,10 +11955,6 @@
               </a:rPr>
               <a:t>Following forward propagation, the network uses a loss function to quantify the discrepancy between the actual and expected outputs, assessing its performance. Reducing this loss is the aim of training. </a:t>
             </a:r>
-            <a:endParaRPr lang="en-US" dirty="0" smtClean="0">
-              <a:latin typeface="Times New Roman" panose="02020603050405020304" pitchFamily="18" charset="0"/>
-              <a:cs typeface="Times New Roman" panose="02020603050405020304" pitchFamily="18" charset="0"/>
-            </a:endParaRPr>
           </a:p>
           <a:p>
             <a:endParaRPr lang="en-US" dirty="0">
@@ -12081,21 +11978,14 @@
                 <a:latin typeface="Times New Roman" panose="02020603050405020304" pitchFamily="18" charset="0"/>
                 <a:cs typeface="Times New Roman" panose="02020603050405020304" pitchFamily="18" charset="0"/>
               </a:rPr>
-              <a:t>: The network determines the loss, which gives an indication of the prediction error</a:t>
-            </a:r>
-            <a:r>
-              <a:rPr lang="en-US" dirty="0" smtClean="0">
-                <a:latin typeface="Times New Roman" panose="02020603050405020304" pitchFamily="18" charset="0"/>
-                <a:cs typeface="Times New Roman" panose="02020603050405020304" pitchFamily="18" charset="0"/>
-              </a:rPr>
-              <a:t>.</a:t>
+              <a:t>: The network determines the loss, which gives an indication of the prediction error.</a:t>
             </a:r>
           </a:p>
           <a:p>
             <a:pPr marL="0" indent="0">
               <a:buNone/>
             </a:pPr>
-            <a:endParaRPr lang="en-US" dirty="0" smtClean="0">
+            <a:endParaRPr lang="en-US" dirty="0">
               <a:latin typeface="Times New Roman" panose="02020603050405020304" pitchFamily="18" charset="0"/>
               <a:cs typeface="Times New Roman" panose="02020603050405020304" pitchFamily="18" charset="0"/>
             </a:endParaRPr>
@@ -12105,39 +11995,25 @@
               <a:buNone/>
             </a:pPr>
             <a:r>
-              <a:rPr lang="en-US" b="1" dirty="0" smtClean="0">
-                <a:latin typeface="Times New Roman" panose="02020603050405020304" pitchFamily="18" charset="0"/>
-                <a:cs typeface="Times New Roman" panose="02020603050405020304" pitchFamily="18" charset="0"/>
-              </a:rPr>
-              <a:t>Gradient </a:t>
-            </a:r>
-            <a:r>
               <a:rPr lang="en-US" b="1" dirty="0">
                 <a:latin typeface="Times New Roman" panose="02020603050405020304" pitchFamily="18" charset="0"/>
                 <a:cs typeface="Times New Roman" panose="02020603050405020304" pitchFamily="18" charset="0"/>
               </a:rPr>
-              <a:t>Calculation</a:t>
-            </a:r>
-            <a:r>
-              <a:rPr lang="en-US" dirty="0">
-                <a:latin typeface="Times New Roman" panose="02020603050405020304" pitchFamily="18" charset="0"/>
-                <a:cs typeface="Times New Roman" panose="02020603050405020304" pitchFamily="18" charset="0"/>
-              </a:rPr>
-              <a:t>: The network calculates the gradients of the loss function in relation to each network weight and bias</a:t>
-            </a:r>
-            <a:r>
-              <a:rPr lang="en-US" dirty="0" smtClean="0">
-                <a:latin typeface="Times New Roman" panose="02020603050405020304" pitchFamily="18" charset="0"/>
-                <a:cs typeface="Times New Roman" panose="02020603050405020304" pitchFamily="18" charset="0"/>
-              </a:rPr>
-              <a:t>.</a:t>
+              <a:t>Gradient Calculation</a:t>
+            </a:r>
+            <a:r>
+              <a:rPr lang="en-US" dirty="0">
+                <a:latin typeface="Times New Roman" panose="02020603050405020304" pitchFamily="18" charset="0"/>
+                <a:cs typeface="Times New Roman" panose="02020603050405020304" pitchFamily="18" charset="0"/>
+              </a:rPr>
+              <a:t>: The network calculates the gradients of the loss function in relation to each network weight and bias.</a:t>
             </a:r>
           </a:p>
           <a:p>
             <a:pPr marL="0" indent="0">
               <a:buNone/>
             </a:pPr>
-            <a:endParaRPr lang="en-US" dirty="0" smtClean="0">
+            <a:endParaRPr lang="en-US" dirty="0">
               <a:latin typeface="Times New Roman" panose="02020603050405020304" pitchFamily="18" charset="0"/>
               <a:cs typeface="Times New Roman" panose="02020603050405020304" pitchFamily="18" charset="0"/>
             </a:endParaRPr>
@@ -12147,18 +12023,11 @@
               <a:buNone/>
             </a:pPr>
             <a:r>
-              <a:rPr lang="en-US" b="1" dirty="0" smtClean="0">
-                <a:latin typeface="Times New Roman" panose="02020603050405020304" pitchFamily="18" charset="0"/>
-                <a:cs typeface="Times New Roman" panose="02020603050405020304" pitchFamily="18" charset="0"/>
-              </a:rPr>
-              <a:t>Weight </a:t>
-            </a:r>
-            <a:r>
               <a:rPr lang="en-US" b="1" dirty="0">
                 <a:latin typeface="Times New Roman" panose="02020603050405020304" pitchFamily="18" charset="0"/>
                 <a:cs typeface="Times New Roman" panose="02020603050405020304" pitchFamily="18" charset="0"/>
               </a:rPr>
-              <a:t>Update</a:t>
+              <a:t>Weight Update</a:t>
             </a:r>
             <a:r>
               <a:rPr lang="en-US" dirty="0">
@@ -12344,23 +12213,12 @@
           <a:lstStyle/>
           <a:p>
             <a:r>
-              <a:rPr lang="en-US" dirty="0" smtClean="0">
-                <a:latin typeface="Times New Roman" panose="02020603050405020304" pitchFamily="18" charset="0"/>
-                <a:cs typeface="Times New Roman" panose="02020603050405020304" pitchFamily="18" charset="0"/>
-              </a:rPr>
-              <a:t>Early wildfire </a:t>
-            </a:r>
-            <a:r>
-              <a:rPr lang="en-US" dirty="0">
-                <a:latin typeface="Times New Roman" panose="02020603050405020304" pitchFamily="18" charset="0"/>
-                <a:cs typeface="Times New Roman" panose="02020603050405020304" pitchFamily="18" charset="0"/>
-              </a:rPr>
-              <a:t>indication directly from a live video stream by performing low-latency, low-power per-pixel classification on an FPGA is targeted.        	- wildfires cause severe environmental and economic damage 	 -early detection is essential to minimizing their spread. </a:t>
-            </a:r>
-            <a:endParaRPr lang="en-US" dirty="0" smtClean="0">
-              <a:latin typeface="Times New Roman" panose="02020603050405020304" pitchFamily="18" charset="0"/>
-              <a:cs typeface="Times New Roman" panose="02020603050405020304" pitchFamily="18" charset="0"/>
-            </a:endParaRPr>
+              <a:rPr lang="en-US" dirty="0">
+                <a:latin typeface="Times New Roman" panose="02020603050405020304" pitchFamily="18" charset="0"/>
+                <a:cs typeface="Times New Roman" panose="02020603050405020304" pitchFamily="18" charset="0"/>
+              </a:rPr>
+              <a:t>Early wildfire indication directly from a live video stream by performing low-latency, low-power per-pixel classification on an FPGA is targeted.        	- wildfires cause severe environmental and economic damage 	 -early detection is essential to minimizing their spread. </a:t>
+            </a:r>
           </a:p>
           <a:p>
             <a:endParaRPr lang="en-US" dirty="0">
@@ -12374,21 +12232,7 @@
                 <a:latin typeface="Times New Roman" panose="02020603050405020304" pitchFamily="18" charset="0"/>
                 <a:cs typeface="Times New Roman" panose="02020603050405020304" pitchFamily="18" charset="0"/>
               </a:rPr>
-              <a:t>Compared to </a:t>
-            </a:r>
-            <a:r>
-              <a:rPr lang="en-US" dirty="0" smtClean="0">
-                <a:latin typeface="Times New Roman" panose="02020603050405020304" pitchFamily="18" charset="0"/>
-                <a:cs typeface="Times New Roman" panose="02020603050405020304" pitchFamily="18" charset="0"/>
-              </a:rPr>
-              <a:t>cloud-based </a:t>
-            </a:r>
-            <a:r>
-              <a:rPr lang="en-US" dirty="0">
-                <a:latin typeface="Times New Roman" panose="02020603050405020304" pitchFamily="18" charset="0"/>
-                <a:cs typeface="Times New Roman" panose="02020603050405020304" pitchFamily="18" charset="0"/>
-              </a:rPr>
-              <a:t>or GPU-based AI solutions, an FPGA edge implementation can avoid the high latency and power draw that often limit real-time deployment.</a:t>
+              <a:t>Compared to cloud-based or GPU-based AI solutions, an FPGA edge implementation can avoid the high latency and power draw that often limit real-time deployment.</a:t>
             </a:r>
             <a:endParaRPr dirty="0">
               <a:latin typeface="Times New Roman" panose="02020603050405020304" pitchFamily="18" charset="0"/>

</xml_diff>